<commit_message>
slides: chem inventory now WordPress-SSO gated (resolved 2026-06-25) in Security-Model + Chemical-Inventory decks; rebuild .pptx
</commit_message>
<xml_diff>
--- a/presentation/UNanofabTools/flaskserver/slides/09-Chemical-Inventory.pptx
+++ b/presentation/UNanofabTools/flaskserver/slides/09-Chemical-Inventory.pptx
@@ -693,7 +693,7 @@
           <a:p>
             <a:r>
               <a:rPr lang="en-US" dirty="0"/>
-              <a:t>Two candid maintenance notes, kept off the main story but recorded for whoever maintains this. First, the type-ahead and auto-fill helpers are unfinished stubs that return nothing, so those niceties don't work yet. Second — more important — the inventory pages currently don't require login, including the pages that change or remove data. That's convenient for a read-only kiosk but a real gap for the editing actions; the recommendation is to require login on at least the changing pages. Both items are in the separate issues list.</a:t>
+              <a:t>Two candid maintenance notes, kept off the main story but recorded for whoever maintains this. First, the type-ahead and auto-fill helpers are unfinished stubs that return nothing, so those niceties don't work yet. Second — more important — the chem pages used to require no login, including the pages that change or remove data — but that was resolved on 2026-06-25: they are now gated by a WordPress single-sign-on, so every /chem page requires a session granted via a signed staff-tools link (/chem/enter), covering reads and edits alike. The type-ahead/auto-fill stubs remain on the separate issues list.</a:t>
             </a:r>
             <a:endParaRPr lang="en-US" dirty="0"/>
           </a:p>
@@ -3086,7 +3086,7 @@
                 <a:ea typeface="Georgia" pitchFamily="34" charset="-122"/>
                 <a:cs typeface="Georgia" pitchFamily="34" charset="-120"/>
               </a:rPr>
-              <a:t>Access is open</a:t>
+              <a:t>Access: WordPress SSO gate</a:t>
             </a:r>
             <a:endParaRPr lang="en-US" sz="1600" dirty="0"/>
           </a:p>
@@ -3129,7 +3129,7 @@
                 <a:ea typeface="Calibri" pitchFamily="34" charset="-122"/>
                 <a:cs typeface="Calibri" pitchFamily="34" charset="-120"/>
               </a:rPr>
-              <a:t>The inventory pages don't currently require login.</a:t>
+              <a:t>All chem pages require a WordPress staff-tools sign-in (since 2026-06-25).</a:t>
             </a:r>
             <a:endParaRPr lang="en-US" sz="1350" dirty="0"/>
           </a:p>
@@ -3150,7 +3150,7 @@
                 <a:ea typeface="Calibri" pitchFamily="34" charset="-122"/>
                 <a:cs typeface="Calibri" pitchFamily="34" charset="-120"/>
               </a:rPr>
-              <a:t>Fine for reading at a kiosk; risky for the edit/remove pages.</a:t>
+              <a:t>Read and edit/remove are both behind the gate.</a:t>
             </a:r>
             <a:endParaRPr lang="en-US" sz="1350" dirty="0"/>
           </a:p>
@@ -3171,7 +3171,7 @@
                 <a:ea typeface="Calibri" pitchFamily="34" charset="-122"/>
                 <a:cs typeface="Calibri" pitchFamily="34" charset="-120"/>
               </a:rPr>
-              <a:t>Recommended to gate the changing actions behind login.</a:t>
+              <a:t>Entry is via a signed /chem/enter link; no public access.</a:t>
             </a:r>
             <a:endParaRPr lang="en-US" sz="1350" dirty="0"/>
           </a:p>

</xml_diff>